<commit_message>
Deck: fondo oscuro de seccion (Break Section) a #1a56db (azul Perpetual)
Solo deck, no se toca el token --bg-dark del design system.

Co-Authored-By: Claude Opus 4.8 (1M context) <noreply@anthropic.com>
</commit_message>
<xml_diff>
--- a/dist/perpetual-deck-template.pptx
+++ b/dist/perpetual-deck-template.pptx
@@ -17665,7 +17665,7 @@
     <p:bg>
       <p:bgPr>
         <a:solidFill>
-          <a:srgbClr val="0B1220"/>
+          <a:srgbClr val="1A56DB"/>
         </a:solidFill>
         <a:effectLst/>
       </p:bgPr>
@@ -17692,7 +17692,7 @@
             <a:avLst/>
           </a:prstGeom>
           <a:solidFill>
-            <a:srgbClr val="131C2E"/>
+            <a:srgbClr val="123F9E"/>
           </a:solidFill>
           <a:ln>
             <a:noFill/>
@@ -17736,7 +17736,7 @@
             <a:avLst/>
           </a:prstGeom>
           <a:solidFill>
-            <a:srgbClr val="1A56DB"/>
+            <a:srgbClr val="FBB900"/>
           </a:solidFill>
           <a:ln>
             <a:noFill/>
@@ -17824,7 +17824,7 @@
             <a:avLst/>
           </a:prstGeom>
           <a:solidFill>
-            <a:srgbClr val="FBB900"/>
+            <a:srgbClr val="FFFFFF"/>
           </a:solidFill>
           <a:ln>
             <a:noFill/>
@@ -17888,7 +17888,7 @@
             <a:r>
               <a:rPr sz="4600" b="0">
                 <a:solidFill>
-                  <a:srgbClr val="1A56DB"/>
+                  <a:srgbClr val="FBB900"/>
                 </a:solidFill>
                 <a:latin typeface="Armin Grotesk Black"/>
               </a:rPr>
@@ -17923,7 +17923,7 @@
             <a:r>
               <a:rPr sz="1500" b="0">
                 <a:solidFill>
-                  <a:srgbClr val="9AA6BD"/>
+                  <a:srgbClr val="C7D7F5"/>
                 </a:solidFill>
                 <a:latin typeface="Armin Grotesk Normal"/>
               </a:rPr>

</xml_diff>